<commit_message>
reframe AI Shopping Assistant as AI Sales Associate
- slide 4: "What an AI Sales Associate changes"
- slide 8 title: "AI Sales Associate on your website that guides
  buyers to the right purchase"
- slide 8 bullets: emphasize guided selling, revenue generation,
  acting like your best in-store sales associate
- slide 12 title: "Your AI sales associate doesn't just search —
  it sells"
- slide 12: "Like your best sales associate, it clarifies intent"

Co-Authored-By: Claude Opus 4.6 (1M context) <noreply@anthropic.com>
</commit_message>
<xml_diff>
--- a/_base_template.pptx
+++ b/_base_template.pptx
@@ -5140,298 +5140,6 @@
 <file path=ppt/slides/slide10.xml><?xml version="1.0" encoding="utf-8"?>
 <p:sld xmlns:a="http://schemas.openxmlformats.org/drawingml/2006/main" xmlns:r="http://schemas.openxmlformats.org/officeDocument/2006/relationships" xmlns:mc="http://schemas.openxmlformats.org/markup-compatibility/2006" xmlns:mv="urn:schemas-microsoft-com:mac:vml" xmlns:p="http://schemas.openxmlformats.org/presentationml/2006/main" xmlns:c="http://schemas.openxmlformats.org/drawingml/2006/chart" xmlns:dgm="http://schemas.openxmlformats.org/drawingml/2006/diagram" xmlns:o="urn:schemas-microsoft-com:office:office" xmlns:v="urn:schemas-microsoft-com:vml" xmlns:pvml="urn:schemas-microsoft-com:office:powerpoint" xmlns:com="http://schemas.openxmlformats.org/drawingml/2006/compatibility" xmlns:p14="http://schemas.microsoft.com/office/powerpoint/2010/main" xmlns:p15="http://schemas.microsoft.com/office/powerpoint/2012/main" xmlns:ahyp="http://schemas.microsoft.com/office/drawing/2018/hyperlinkcolor">
   <p:cSld>
-    <p:spTree>
-      <p:nvGrpSpPr>
-        <p:cNvPr id="125" name="Shape 125"/>
-        <p:cNvGrpSpPr/>
-        <p:nvPr/>
-      </p:nvGrpSpPr>
-      <p:grpSpPr>
-        <a:xfrm>
-          <a:off x="0" y="0"/>
-          <a:ext cx="0" cy="0"/>
-          <a:chOff x="0" y="0"/>
-          <a:chExt cx="0" cy="0"/>
-        </a:xfrm>
-      </p:grpSpPr>
-      <p:sp>
-        <p:nvSpPr>
-          <p:cNvPr id="126" name="Google Shape;126;g3d836f29ee0_0_17"/>
-          <p:cNvSpPr txBox="1"/>
-          <p:nvPr/>
-        </p:nvSpPr>
-        <p:spPr>
-          <a:xfrm>
-            <a:off x="410725" y="260850"/>
-            <a:ext cx="8475600" cy="787200"/>
-          </a:xfrm>
-          <a:prstGeom prst="rect">
-            <a:avLst/>
-          </a:prstGeom>
-          <a:noFill/>
-          <a:ln>
-            <a:noFill/>
-          </a:ln>
-        </p:spPr>
-        <p:txBody>
-          <a:bodyPr anchorCtr="0" anchor="t" bIns="91425" lIns="91425" spcFirstLastPara="1" rIns="91425" wrap="square" tIns="91425">
-            <a:noAutofit/>
-          </a:bodyPr>
-          <a:lstStyle/>
-          <a:p>
-            <a:pPr indent="0" lvl="0" marL="0" rtl="0" algn="l">
-              <a:spcBef>
-                <a:spcPts val="0"/>
-              </a:spcBef>
-              <a:spcAft>
-                <a:spcPts val="0"/>
-              </a:spcAft>
-              <a:buNone/>
-            </a:pPr>
-            <a:r>
-              <a:rPr b="1" lang="en-US" sz="2000"/>
-              <a:t>The future of e-commerce - shopping assistants, virtual try-on, multilingual queries and discovery through apps on LLM platforms.</a:t>
-            </a:r>
-            <a:endParaRPr b="1" sz="2000"/>
-          </a:p>
-        </p:txBody>
-      </p:sp>
-      <p:sp>
-        <p:nvSpPr>
-          <p:cNvPr id="127" name="Google Shape;127;g3d836f29ee0_0_17"/>
-          <p:cNvSpPr txBox="1"/>
-          <p:nvPr/>
-        </p:nvSpPr>
-        <p:spPr>
-          <a:xfrm>
-            <a:off x="345025" y="1274475"/>
-            <a:ext cx="8238300" cy="3429000"/>
-          </a:xfrm>
-          <a:prstGeom prst="rect">
-            <a:avLst/>
-          </a:prstGeom>
-          <a:noFill/>
-          <a:ln>
-            <a:noFill/>
-          </a:ln>
-        </p:spPr>
-        <p:txBody>
-          <a:bodyPr anchorCtr="0" anchor="t" bIns="91425" lIns="91425" spcFirstLastPara="1" rIns="91425" wrap="square" tIns="91425">
-            <a:noAutofit/>
-          </a:bodyPr>
-          <a:lstStyle/>
-          <a:p>
-            <a:pPr indent="0" lvl="0" marL="0" rtl="0" algn="l">
-              <a:spcBef>
-                <a:spcPts val="0"/>
-              </a:spcBef>
-              <a:spcAft>
-                <a:spcPts val="0"/>
-              </a:spcAft>
-              <a:buNone/>
-            </a:pPr>
-            <a:r>
-              <a:rPr lang="en-US"/>
-              <a:t xml:space="preserve">Buyers today are increasingly looking for virtual try-on to make more informed </a:t>
-            </a:r>
-            <a:r>
-              <a:rPr lang="en-US"/>
-              <a:t>decisions</a:t>
-            </a:r>
-            <a:r>
-              <a:rPr lang="en-US"/>
-              <a:t>.</a:t>
-            </a:r>
-            <a:endParaRPr/>
-          </a:p>
-          <a:p>
-            <a:pPr indent="0" lvl="0" marL="0" rtl="0" algn="l">
-              <a:spcBef>
-                <a:spcPts val="0"/>
-              </a:spcBef>
-              <a:spcAft>
-                <a:spcPts val="0"/>
-              </a:spcAft>
-              <a:buNone/>
-            </a:pPr>
-            <a:r>
-              <a:t/>
-            </a:r>
-            <a:endParaRPr/>
-          </a:p>
-          <a:p>
-            <a:pPr indent="0" lvl="0" marL="0" rtl="0" algn="l">
-              <a:spcBef>
-                <a:spcPts val="0"/>
-              </a:spcBef>
-              <a:spcAft>
-                <a:spcPts val="0"/>
-              </a:spcAft>
-              <a:buNone/>
-            </a:pPr>
-            <a:r>
-              <a:rPr lang="en-US"/>
-              <a:t>More and more numbers of queries are being asked in multilingual languages as e-commerce spreads to tier 2 and 3 cities.</a:t>
-            </a:r>
-            <a:endParaRPr/>
-          </a:p>
-          <a:p>
-            <a:pPr indent="0" lvl="0" marL="0" rtl="0" algn="l">
-              <a:spcBef>
-                <a:spcPts val="0"/>
-              </a:spcBef>
-              <a:spcAft>
-                <a:spcPts val="0"/>
-              </a:spcAft>
-              <a:buNone/>
-            </a:pPr>
-            <a:r>
-              <a:t/>
-            </a:r>
-            <a:endParaRPr/>
-          </a:p>
-          <a:p>
-            <a:pPr indent="0" lvl="0" marL="0" rtl="0" algn="l">
-              <a:spcBef>
-                <a:spcPts val="0"/>
-              </a:spcBef>
-              <a:spcAft>
-                <a:spcPts val="0"/>
-              </a:spcAft>
-              <a:buNone/>
-            </a:pPr>
-            <a:r>
-              <a:rPr b="1" lang="en-US"/>
-              <a:t xml:space="preserve">40% of shoppers now start their discovery journey on some AI chat agent </a:t>
-            </a:r>
-            <a:r>
-              <a:rPr lang="en-US"/>
-              <a:t xml:space="preserve">such as Gemini/ChatGPT/Perplexity. </a:t>
-            </a:r>
-            <a:endParaRPr/>
-          </a:p>
-          <a:p>
-            <a:pPr indent="0" lvl="0" marL="0" rtl="0" algn="l">
-              <a:spcBef>
-                <a:spcPts val="0"/>
-              </a:spcBef>
-              <a:spcAft>
-                <a:spcPts val="0"/>
-              </a:spcAft>
-              <a:buNone/>
-            </a:pPr>
-            <a:r>
-              <a:t/>
-            </a:r>
-            <a:endParaRPr/>
-          </a:p>
-          <a:p>
-            <a:pPr indent="0" lvl="0" marL="0" rtl="0" algn="l">
-              <a:spcBef>
-                <a:spcPts val="0"/>
-              </a:spcBef>
-              <a:spcAft>
-                <a:spcPts val="0"/>
-              </a:spcAft>
-              <a:buNone/>
-            </a:pPr>
-            <a:r>
-              <a:rPr lang="en-US"/>
-              <a:t>Before reaching a brand’s website, buyers first discover brand</a:t>
-            </a:r>
-            <a:r>
-              <a:rPr lang="en-US"/>
-              <a:t>s</a:t>
-            </a:r>
-            <a:r>
-              <a:rPr lang="en-US"/>
-              <a:t xml:space="preserve"> through LLMs. While AEO/GEO ensures that a brand comes up in the LLM’s suggestions, that is just the first part. Brands have to also ensure that buyers can </a:t>
-            </a:r>
-            <a:r>
-              <a:rPr lang="en-US"/>
-              <a:t>interact</a:t>
-            </a:r>
-            <a:r>
-              <a:rPr lang="en-US"/>
-              <a:t xml:space="preserve"> </a:t>
-            </a:r>
-            <a:r>
-              <a:rPr lang="en-US"/>
-              <a:t>with</a:t>
-            </a:r>
-            <a:r>
-              <a:rPr lang="en-US"/>
-              <a:t xml:space="preserve"> their catalogs within the LLM chat interface itself so they come to their website and buy.</a:t>
-            </a:r>
-            <a:endParaRPr/>
-          </a:p>
-          <a:p>
-            <a:pPr indent="0" lvl="0" marL="0" rtl="0" algn="l">
-              <a:spcBef>
-                <a:spcPts val="0"/>
-              </a:spcBef>
-              <a:spcAft>
-                <a:spcPts val="0"/>
-              </a:spcAft>
-              <a:buNone/>
-            </a:pPr>
-            <a:r>
-              <a:t/>
-            </a:r>
-            <a:endParaRPr/>
-          </a:p>
-          <a:p>
-            <a:pPr indent="0" lvl="0" marL="0" rtl="0" algn="l">
-              <a:spcBef>
-                <a:spcPts val="0"/>
-              </a:spcBef>
-              <a:spcAft>
-                <a:spcPts val="0"/>
-              </a:spcAft>
-              <a:buNone/>
-            </a:pPr>
-            <a:r>
-              <a:rPr lang="en-US"/>
-              <a:t xml:space="preserve">As a result </a:t>
-            </a:r>
-            <a:r>
-              <a:rPr b="1" lang="en-US"/>
-              <a:t>Walmart, Sephora, Instacart, Doordash</a:t>
-            </a:r>
-            <a:r>
-              <a:rPr lang="en-US"/>
-              <a:t xml:space="preserve"> have already created apps on top of ChatGPT to capture buyers upfront.</a:t>
-            </a:r>
-            <a:endParaRPr/>
-          </a:p>
-          <a:p>
-            <a:pPr indent="0" lvl="0" marL="0" rtl="0" algn="l">
-              <a:spcBef>
-                <a:spcPts val="0"/>
-              </a:spcBef>
-              <a:spcAft>
-                <a:spcPts val="0"/>
-              </a:spcAft>
-              <a:buNone/>
-            </a:pPr>
-            <a:r>
-              <a:t/>
-            </a:r>
-            <a:endParaRPr/>
-          </a:p>
-        </p:txBody>
-      </p:sp>
-    </p:spTree>
-  </p:cSld>
-  <p:clrMapOvr>
-    <a:masterClrMapping/>
-  </p:clrMapOvr>
-</p:sld>
-</file>
-
-<file path=ppt/slides/slide11.xml><?xml version="1.0" encoding="utf-8"?>
-<p:sld xmlns:a="http://schemas.openxmlformats.org/drawingml/2006/main" xmlns:r="http://schemas.openxmlformats.org/officeDocument/2006/relationships" xmlns:mc="http://schemas.openxmlformats.org/markup-compatibility/2006" xmlns:mv="urn:schemas-microsoft-com:mac:vml" xmlns:p="http://schemas.openxmlformats.org/presentationml/2006/main" xmlns:c="http://schemas.openxmlformats.org/drawingml/2006/chart" xmlns:dgm="http://schemas.openxmlformats.org/drawingml/2006/diagram" xmlns:o="urn:schemas-microsoft-com:office:office" xmlns:v="urn:schemas-microsoft-com:vml" xmlns:pvml="urn:schemas-microsoft-com:office:powerpoint" xmlns:com="http://schemas.openxmlformats.org/drawingml/2006/compatibility" xmlns:p14="http://schemas.microsoft.com/office/powerpoint/2010/main" xmlns:p15="http://schemas.microsoft.com/office/powerpoint/2012/main" xmlns:ahyp="http://schemas.microsoft.com/office/drawing/2018/hyperlinkcolor">
-  <p:cSld>
     <p:bg>
       <p:bgPr>
         <a:solidFill>
@@ -6262,7 +5970,7 @@
 </p:sld>
 </file>
 
-<file path=ppt/slides/slide12.xml><?xml version="1.0" encoding="utf-8"?>
+<file path=ppt/slides/slide11.xml><?xml version="1.0" encoding="utf-8"?>
 <p:sld xmlns:a="http://schemas.openxmlformats.org/drawingml/2006/main" xmlns:r="http://schemas.openxmlformats.org/officeDocument/2006/relationships" xmlns:mc="http://schemas.openxmlformats.org/markup-compatibility/2006" xmlns:mv="urn:schemas-microsoft-com:mac:vml" xmlns:p="http://schemas.openxmlformats.org/presentationml/2006/main" xmlns:c="http://schemas.openxmlformats.org/drawingml/2006/chart" xmlns:dgm="http://schemas.openxmlformats.org/drawingml/2006/diagram" xmlns:o="urn:schemas-microsoft-com:office:office" xmlns:v="urn:schemas-microsoft-com:vml" xmlns:pvml="urn:schemas-microsoft-com:office:powerpoint" xmlns:com="http://schemas.openxmlformats.org/drawingml/2006/compatibility" xmlns:p14="http://schemas.microsoft.com/office/powerpoint/2010/main" xmlns:p15="http://schemas.microsoft.com/office/powerpoint/2012/main" xmlns:ahyp="http://schemas.microsoft.com/office/drawing/2018/hyperlinkcolor">
   <p:cSld>
     <p:spTree>
@@ -6380,7 +6088,7 @@
 </p:sld>
 </file>
 
-<file path=ppt/slides/slide13.xml><?xml version="1.0" encoding="utf-8"?>
+<file path=ppt/slides/slide12.xml><?xml version="1.0" encoding="utf-8"?>
 <p:sld xmlns:a="http://schemas.openxmlformats.org/drawingml/2006/main" xmlns:r="http://schemas.openxmlformats.org/officeDocument/2006/relationships" xmlns:mc="http://schemas.openxmlformats.org/markup-compatibility/2006" xmlns:mv="urn:schemas-microsoft-com:mac:vml" xmlns:p="http://schemas.openxmlformats.org/presentationml/2006/main" xmlns:c="http://schemas.openxmlformats.org/drawingml/2006/chart" xmlns:dgm="http://schemas.openxmlformats.org/drawingml/2006/diagram" xmlns:o="urn:schemas-microsoft-com:office:office" xmlns:v="urn:schemas-microsoft-com:vml" xmlns:pvml="urn:schemas-microsoft-com:office:powerpoint" xmlns:com="http://schemas.openxmlformats.org/drawingml/2006/compatibility" xmlns:p14="http://schemas.microsoft.com/office/powerpoint/2010/main" xmlns:p15="http://schemas.microsoft.com/office/powerpoint/2012/main" xmlns:ahyp="http://schemas.microsoft.com/office/drawing/2018/hyperlinkcolor">
   <p:cSld>
     <p:spTree>
@@ -6508,7 +6216,7 @@
                 <a:cs typeface="Inter"/>
                 <a:sym typeface="Inter"/>
               </a:rPr>
-              <a:t>An AI shopping assistant doesn't just search — it sells</a:t>
+              <a:t>Your AI sales associate doesn't just search — it sells</a:t>
             </a:r>
             <a:endParaRPr b="0" i="0" sz="2300" u="none" cap="none" strike="noStrike">
               <a:solidFill>
@@ -6699,7 +6407,7 @@
                 <a:cs typeface="Inter"/>
                 <a:sym typeface="Inter"/>
               </a:rPr>
-              <a:t>Clarifies intent instead of dumping a catalog — asks the right follow-up questions (occasion, budget, use-case, size/fit) before suggesting anything.</a:t>
+              <a:t>Like your best sales associate, it clarifies intent instead of dumping a catalog — asks the right follow-up questions (occasion, budget, use-case, size/fit) before suggesting anything.</a:t>
             </a:r>
             <a:endParaRPr b="0" i="0" sz="1100" u="none" cap="none" strike="noStrike">
               <a:solidFill>
@@ -7343,7 +7051,7 @@
 </p:sld>
 </file>
 
-<file path=ppt/slides/slide14.xml><?xml version="1.0" encoding="utf-8"?>
+<file path=ppt/slides/slide13.xml><?xml version="1.0" encoding="utf-8"?>
 <p:sld xmlns:a="http://schemas.openxmlformats.org/drawingml/2006/main" xmlns:r="http://schemas.openxmlformats.org/officeDocument/2006/relationships" xmlns:mc="http://schemas.openxmlformats.org/markup-compatibility/2006" xmlns:mv="urn:schemas-microsoft-com:mac:vml" xmlns:p="http://schemas.openxmlformats.org/presentationml/2006/main" xmlns:c="http://schemas.openxmlformats.org/drawingml/2006/chart" xmlns:dgm="http://schemas.openxmlformats.org/drawingml/2006/diagram" xmlns:o="urn:schemas-microsoft-com:office:office" xmlns:v="urn:schemas-microsoft-com:vml" xmlns:pvml="urn:schemas-microsoft-com:office:powerpoint" xmlns:com="http://schemas.openxmlformats.org/drawingml/2006/compatibility" xmlns:p14="http://schemas.microsoft.com/office/powerpoint/2010/main" xmlns:p15="http://schemas.microsoft.com/office/powerpoint/2012/main" xmlns:ahyp="http://schemas.microsoft.com/office/drawing/2018/hyperlinkcolor">
   <p:cSld>
     <p:bg>
@@ -10515,7 +10223,7 @@
 </p:sld>
 </file>
 
-<file path=ppt/slides/slide15.xml><?xml version="1.0" encoding="utf-8"?>
+<file path=ppt/slides/slide14.xml><?xml version="1.0" encoding="utf-8"?>
 <p:sld xmlns:a="http://schemas.openxmlformats.org/drawingml/2006/main" xmlns:r="http://schemas.openxmlformats.org/officeDocument/2006/relationships" xmlns:mc="http://schemas.openxmlformats.org/markup-compatibility/2006" xmlns:mv="urn:schemas-microsoft-com:mac:vml" xmlns:p="http://schemas.openxmlformats.org/presentationml/2006/main" xmlns:c="http://schemas.openxmlformats.org/drawingml/2006/chart" xmlns:dgm="http://schemas.openxmlformats.org/drawingml/2006/diagram" xmlns:o="urn:schemas-microsoft-com:office:office" xmlns:v="urn:schemas-microsoft-com:vml" xmlns:pvml="urn:schemas-microsoft-com:office:powerpoint" xmlns:com="http://schemas.openxmlformats.org/drawingml/2006/compatibility" xmlns:p14="http://schemas.microsoft.com/office/powerpoint/2010/main" xmlns:p15="http://schemas.microsoft.com/office/powerpoint/2012/main" xmlns:ahyp="http://schemas.microsoft.com/office/drawing/2018/hyperlinkcolor">
   <p:cSld>
     <p:bg>
@@ -14475,7 +14183,7 @@
                 <a:cs typeface="Inter"/>
                 <a:sym typeface="Inter"/>
               </a:rPr>
-              <a:t>What an AI Shopping Assistant changes :  “I need an outfit under 20000 for myself, size medium, for my sister’s beach wedding, I like sequins”</a:t>
+              <a:t>What an AI Sales Associate changes :  “I need an outfit under 20000 for myself, size medium, for my sister’s beach wedding, I like sequins”</a:t>
             </a:r>
             <a:endParaRPr b="0" i="0" sz="1100" u="none" cap="none" strike="noStrike">
               <a:solidFill>
@@ -14515,7 +14223,7 @@
                 <a:cs typeface="Inter"/>
                 <a:sym typeface="Inter"/>
               </a:rPr>
-              <a:t>An AI shopping assistant powered by a knowledge graph understands intent + constraints + context, it maps beach to : pastels/boho, wedding to lehenga/sharara/gown, adds the conditions for sequins and returns relevant products from the catalog - exactly what the shopper means and wants, not just what they typed.</a:t>
+              <a:t>An AI sales associate powered by a knowledge graph understands intent + constraints + context, it maps beach to : pastels/boho, wedding to lehenga/sharara/gown, adds the conditions for sequins and returns relevant products from the catalog - exactly what the shopper means and wants, not just what they typed.</a:t>
             </a:r>
             <a:endParaRPr b="0" i="0" sz="1100" u="none" cap="none" strike="noStrike">
               <a:solidFill>
@@ -16167,7 +15875,7 @@
 </p:sld>
 </file>
 
-<file path=ppt/slides/slide8.xml><?xml version="1.0" encoding="utf-8"?>
+<file path=ppt/slides/slide7.xml><?xml version="1.0" encoding="utf-8"?>
 <p:sld xmlns:a="http://schemas.openxmlformats.org/drawingml/2006/main" xmlns:r="http://schemas.openxmlformats.org/officeDocument/2006/relationships" xmlns:mc="http://schemas.openxmlformats.org/markup-compatibility/2006" xmlns:mv="urn:schemas-microsoft-com:mac:vml" xmlns:p="http://schemas.openxmlformats.org/presentationml/2006/main" xmlns:c="http://schemas.openxmlformats.org/drawingml/2006/chart" xmlns:dgm="http://schemas.openxmlformats.org/drawingml/2006/diagram" xmlns:o="urn:schemas-microsoft-com:office:office" xmlns:v="urn:schemas-microsoft-com:vml" xmlns:pvml="urn:schemas-microsoft-com:office:powerpoint" xmlns:com="http://schemas.openxmlformats.org/drawingml/2006/compatibility" xmlns:p14="http://schemas.microsoft.com/office/powerpoint/2010/main" xmlns:p15="http://schemas.microsoft.com/office/powerpoint/2012/main" xmlns:ahyp="http://schemas.microsoft.com/office/drawing/2018/hyperlinkcolor">
   <p:cSld>
     <p:spTree>
@@ -16424,7 +16132,7 @@
 </p:sld>
 </file>
 
-<file path=ppt/slides/slide9.xml><?xml version="1.0" encoding="utf-8"?>
+<file path=ppt/slides/slide8.xml><?xml version="1.0" encoding="utf-8"?>
 <p:sld xmlns:a="http://schemas.openxmlformats.org/drawingml/2006/main" xmlns:r="http://schemas.openxmlformats.org/officeDocument/2006/relationships" xmlns:mc="http://schemas.openxmlformats.org/markup-compatibility/2006" xmlns:mv="urn:schemas-microsoft-com:mac:vml" xmlns:p="http://schemas.openxmlformats.org/presentationml/2006/main" xmlns:c="http://schemas.openxmlformats.org/drawingml/2006/chart" xmlns:dgm="http://schemas.openxmlformats.org/drawingml/2006/diagram" xmlns:o="urn:schemas-microsoft-com:office:office" xmlns:v="urn:schemas-microsoft-com:vml" xmlns:pvml="urn:schemas-microsoft-com:office:powerpoint" xmlns:com="http://schemas.openxmlformats.org/drawingml/2006/compatibility" xmlns:p14="http://schemas.microsoft.com/office/powerpoint/2010/main" xmlns:p15="http://schemas.microsoft.com/office/powerpoint/2012/main" xmlns:ahyp="http://schemas.microsoft.com/office/drawing/2018/hyperlinkcolor">
   <p:cSld>
     <p:bg>
@@ -16696,7 +16404,7 @@
                 <a:cs typeface="Inter"/>
                 <a:sym typeface="Inter"/>
               </a:rPr>
-              <a:t>AI Shopping Assistant on Website that can understand user intent</a:t>
+              <a:t>AI Sales Associate on your website that guides buyers to the right purchase</a:t>
             </a:r>
             <a:endParaRPr b="0" i="0" sz="1600" u="none" cap="none" strike="noStrike">
               <a:solidFill>
@@ -16762,7 +16470,7 @@
                 <a:cs typeface="Inter"/>
                 <a:sym typeface="Inter"/>
               </a:rPr>
-              <a:t>Chat-based shopping: voice, image, and text input</a:t>
+              <a:t>Acts as a digital sales associate — asks the right questions, understands what the buyer actually needs, and guides them to the right product</a:t>
             </a:r>
             <a:endParaRPr b="0" i="0" sz="1300" u="none" cap="none" strike="noStrike">
               <a:solidFill>
@@ -16802,7 +16510,7 @@
                 <a:cs typeface="Inter"/>
                 <a:sym typeface="Inter"/>
               </a:rPr>
-              <a:t>Lower cost per query - Graph handles 90%+ of queries, LLM tokens only for edge cases</a:t>
+              <a:t>Drives revenue, not just answers — every conversation is a guided selling opportunity that converts browsers into buyers</a:t>
             </a:r>
             <a:endParaRPr b="0" i="0" sz="1300" u="none" cap="none" strike="noStrike">
               <a:solidFill>
@@ -16842,7 +16550,7 @@
                 <a:cs typeface="Inter"/>
                 <a:sym typeface="Inter"/>
               </a:rPr>
-              <a:t>All intent based queries such as “outfit for Ladakh trip”, “plan my meals” handled just like in ChatGPT and Amazon Rufus, giving buyer a full conversational experience.</a:t>
+              <a:t>All intent based queries such as “outfit for Ladakh trip”, “plan my meals” handled just like in ChatGPT and Amazon Rufus, guiding buyers to a purchase just like your best in-store sales associate would.</a:t>
             </a:r>
             <a:endParaRPr b="0" i="0" sz="1300" u="none" cap="none" strike="noStrike">
               <a:solidFill>
@@ -17419,6 +17127,298 @@
               <a:cs typeface="Inter"/>
               <a:sym typeface="Inter"/>
             </a:endParaRPr>
+          </a:p>
+        </p:txBody>
+      </p:sp>
+    </p:spTree>
+  </p:cSld>
+  <p:clrMapOvr>
+    <a:masterClrMapping/>
+  </p:clrMapOvr>
+</p:sld>
+</file>
+
+<file path=ppt/slides/slide9.xml><?xml version="1.0" encoding="utf-8"?>
+<p:sld xmlns:a="http://schemas.openxmlformats.org/drawingml/2006/main" xmlns:r="http://schemas.openxmlformats.org/officeDocument/2006/relationships" xmlns:mc="http://schemas.openxmlformats.org/markup-compatibility/2006" xmlns:mv="urn:schemas-microsoft-com:mac:vml" xmlns:p="http://schemas.openxmlformats.org/presentationml/2006/main" xmlns:c="http://schemas.openxmlformats.org/drawingml/2006/chart" xmlns:dgm="http://schemas.openxmlformats.org/drawingml/2006/diagram" xmlns:o="urn:schemas-microsoft-com:office:office" xmlns:v="urn:schemas-microsoft-com:vml" xmlns:pvml="urn:schemas-microsoft-com:office:powerpoint" xmlns:com="http://schemas.openxmlformats.org/drawingml/2006/compatibility" xmlns:p14="http://schemas.microsoft.com/office/powerpoint/2010/main" xmlns:p15="http://schemas.microsoft.com/office/powerpoint/2012/main" xmlns:ahyp="http://schemas.microsoft.com/office/drawing/2018/hyperlinkcolor">
+  <p:cSld>
+    <p:spTree>
+      <p:nvGrpSpPr>
+        <p:cNvPr id="125" name="Shape 125"/>
+        <p:cNvGrpSpPr/>
+        <p:nvPr/>
+      </p:nvGrpSpPr>
+      <p:grpSpPr>
+        <a:xfrm>
+          <a:off x="0" y="0"/>
+          <a:ext cx="0" cy="0"/>
+          <a:chOff x="0" y="0"/>
+          <a:chExt cx="0" cy="0"/>
+        </a:xfrm>
+      </p:grpSpPr>
+      <p:sp>
+        <p:nvSpPr>
+          <p:cNvPr id="126" name="Google Shape;126;g3d836f29ee0_0_17"/>
+          <p:cNvSpPr txBox="1"/>
+          <p:nvPr/>
+        </p:nvSpPr>
+        <p:spPr>
+          <a:xfrm>
+            <a:off x="410725" y="260850"/>
+            <a:ext cx="8475600" cy="787200"/>
+          </a:xfrm>
+          <a:prstGeom prst="rect">
+            <a:avLst/>
+          </a:prstGeom>
+          <a:noFill/>
+          <a:ln>
+            <a:noFill/>
+          </a:ln>
+        </p:spPr>
+        <p:txBody>
+          <a:bodyPr anchorCtr="0" anchor="t" bIns="91425" lIns="91425" spcFirstLastPara="1" rIns="91425" wrap="square" tIns="91425">
+            <a:noAutofit/>
+          </a:bodyPr>
+          <a:lstStyle/>
+          <a:p>
+            <a:pPr indent="0" lvl="0" marL="0" rtl="0" algn="l">
+              <a:spcBef>
+                <a:spcPts val="0"/>
+              </a:spcBef>
+              <a:spcAft>
+                <a:spcPts val="0"/>
+              </a:spcAft>
+              <a:buNone/>
+            </a:pPr>
+            <a:r>
+              <a:rPr b="1" lang="en-US" sz="2000"/>
+              <a:t>The future of e-commerce - shopping assistants, virtual try-on, multilingual queries and discovery through apps on LLM platforms.</a:t>
+            </a:r>
+            <a:endParaRPr b="1" sz="2000"/>
+          </a:p>
+        </p:txBody>
+      </p:sp>
+      <p:sp>
+        <p:nvSpPr>
+          <p:cNvPr id="127" name="Google Shape;127;g3d836f29ee0_0_17"/>
+          <p:cNvSpPr txBox="1"/>
+          <p:nvPr/>
+        </p:nvSpPr>
+        <p:spPr>
+          <a:xfrm>
+            <a:off x="345025" y="1274475"/>
+            <a:ext cx="8238300" cy="3429000"/>
+          </a:xfrm>
+          <a:prstGeom prst="rect">
+            <a:avLst/>
+          </a:prstGeom>
+          <a:noFill/>
+          <a:ln>
+            <a:noFill/>
+          </a:ln>
+        </p:spPr>
+        <p:txBody>
+          <a:bodyPr anchorCtr="0" anchor="t" bIns="91425" lIns="91425" spcFirstLastPara="1" rIns="91425" wrap="square" tIns="91425">
+            <a:noAutofit/>
+          </a:bodyPr>
+          <a:lstStyle/>
+          <a:p>
+            <a:pPr indent="0" lvl="0" marL="0" rtl="0" algn="l">
+              <a:spcBef>
+                <a:spcPts val="0"/>
+              </a:spcBef>
+              <a:spcAft>
+                <a:spcPts val="0"/>
+              </a:spcAft>
+              <a:buNone/>
+            </a:pPr>
+            <a:r>
+              <a:rPr lang="en-US"/>
+              <a:t xml:space="preserve">Buyers today are increasingly looking for virtual try-on to make more informed </a:t>
+            </a:r>
+            <a:r>
+              <a:rPr lang="en-US"/>
+              <a:t>decisions</a:t>
+            </a:r>
+            <a:r>
+              <a:rPr lang="en-US"/>
+              <a:t>.</a:t>
+            </a:r>
+            <a:endParaRPr/>
+          </a:p>
+          <a:p>
+            <a:pPr indent="0" lvl="0" marL="0" rtl="0" algn="l">
+              <a:spcBef>
+                <a:spcPts val="0"/>
+              </a:spcBef>
+              <a:spcAft>
+                <a:spcPts val="0"/>
+              </a:spcAft>
+              <a:buNone/>
+            </a:pPr>
+            <a:r>
+              <a:t/>
+            </a:r>
+            <a:endParaRPr/>
+          </a:p>
+          <a:p>
+            <a:pPr indent="0" lvl="0" marL="0" rtl="0" algn="l">
+              <a:spcBef>
+                <a:spcPts val="0"/>
+              </a:spcBef>
+              <a:spcAft>
+                <a:spcPts val="0"/>
+              </a:spcAft>
+              <a:buNone/>
+            </a:pPr>
+            <a:r>
+              <a:rPr lang="en-US"/>
+              <a:t>More and more numbers of queries are being asked in multilingual languages as e-commerce spreads to tier 2 and 3 cities.</a:t>
+            </a:r>
+            <a:endParaRPr/>
+          </a:p>
+          <a:p>
+            <a:pPr indent="0" lvl="0" marL="0" rtl="0" algn="l">
+              <a:spcBef>
+                <a:spcPts val="0"/>
+              </a:spcBef>
+              <a:spcAft>
+                <a:spcPts val="0"/>
+              </a:spcAft>
+              <a:buNone/>
+            </a:pPr>
+            <a:r>
+              <a:t/>
+            </a:r>
+            <a:endParaRPr/>
+          </a:p>
+          <a:p>
+            <a:pPr indent="0" lvl="0" marL="0" rtl="0" algn="l">
+              <a:spcBef>
+                <a:spcPts val="0"/>
+              </a:spcBef>
+              <a:spcAft>
+                <a:spcPts val="0"/>
+              </a:spcAft>
+              <a:buNone/>
+            </a:pPr>
+            <a:r>
+              <a:rPr b="1" lang="en-US"/>
+              <a:t xml:space="preserve">40% of shoppers now start their discovery journey on some AI chat agent </a:t>
+            </a:r>
+            <a:r>
+              <a:rPr lang="en-US"/>
+              <a:t xml:space="preserve">such as Gemini/ChatGPT/Perplexity. </a:t>
+            </a:r>
+            <a:endParaRPr/>
+          </a:p>
+          <a:p>
+            <a:pPr indent="0" lvl="0" marL="0" rtl="0" algn="l">
+              <a:spcBef>
+                <a:spcPts val="0"/>
+              </a:spcBef>
+              <a:spcAft>
+                <a:spcPts val="0"/>
+              </a:spcAft>
+              <a:buNone/>
+            </a:pPr>
+            <a:r>
+              <a:t/>
+            </a:r>
+            <a:endParaRPr/>
+          </a:p>
+          <a:p>
+            <a:pPr indent="0" lvl="0" marL="0" rtl="0" algn="l">
+              <a:spcBef>
+                <a:spcPts val="0"/>
+              </a:spcBef>
+              <a:spcAft>
+                <a:spcPts val="0"/>
+              </a:spcAft>
+              <a:buNone/>
+            </a:pPr>
+            <a:r>
+              <a:rPr lang="en-US"/>
+              <a:t>Before reaching a brand’s website, buyers first discover brand</a:t>
+            </a:r>
+            <a:r>
+              <a:rPr lang="en-US"/>
+              <a:t>s</a:t>
+            </a:r>
+            <a:r>
+              <a:rPr lang="en-US"/>
+              <a:t xml:space="preserve"> through LLMs. While AEO/GEO ensures that a brand comes up in the LLM’s suggestions, that is just the first part. Brands have to also ensure that buyers can </a:t>
+            </a:r>
+            <a:r>
+              <a:rPr lang="en-US"/>
+              <a:t>interact</a:t>
+            </a:r>
+            <a:r>
+              <a:rPr lang="en-US"/>
+              <a:t xml:space="preserve"> </a:t>
+            </a:r>
+            <a:r>
+              <a:rPr lang="en-US"/>
+              <a:t>with</a:t>
+            </a:r>
+            <a:r>
+              <a:rPr lang="en-US"/>
+              <a:t xml:space="preserve"> their catalogs within the LLM chat interface itself so they come to their website and buy.</a:t>
+            </a:r>
+            <a:endParaRPr/>
+          </a:p>
+          <a:p>
+            <a:pPr indent="0" lvl="0" marL="0" rtl="0" algn="l">
+              <a:spcBef>
+                <a:spcPts val="0"/>
+              </a:spcBef>
+              <a:spcAft>
+                <a:spcPts val="0"/>
+              </a:spcAft>
+              <a:buNone/>
+            </a:pPr>
+            <a:r>
+              <a:t/>
+            </a:r>
+            <a:endParaRPr/>
+          </a:p>
+          <a:p>
+            <a:pPr indent="0" lvl="0" marL="0" rtl="0" algn="l">
+              <a:spcBef>
+                <a:spcPts val="0"/>
+              </a:spcBef>
+              <a:spcAft>
+                <a:spcPts val="0"/>
+              </a:spcAft>
+              <a:buNone/>
+            </a:pPr>
+            <a:r>
+              <a:rPr lang="en-US"/>
+              <a:t xml:space="preserve">As a result </a:t>
+            </a:r>
+            <a:r>
+              <a:rPr b="1" lang="en-US"/>
+              <a:t>Walmart, Sephora, Instacart, Doordash</a:t>
+            </a:r>
+            <a:r>
+              <a:rPr lang="en-US"/>
+              <a:t xml:space="preserve"> have already created apps on top of ChatGPT to capture buyers upfront.</a:t>
+            </a:r>
+            <a:endParaRPr/>
+          </a:p>
+          <a:p>
+            <a:pPr indent="0" lvl="0" marL="0" rtl="0" algn="l">
+              <a:spcBef>
+                <a:spcPts val="0"/>
+              </a:spcBef>
+              <a:spcAft>
+                <a:spcPts val="0"/>
+              </a:spcAft>
+              <a:buNone/>
+            </a:pPr>
+            <a:r>
+              <a:t/>
+            </a:r>
+            <a:endParaRPr/>
           </a:p>
         </p:txBody>
       </p:sp>

</xml_diff>

<commit_message>
comprehensive review fixes across all 6 templates
base template:
- fix "for for" typo on slide 1
- fix double period on slide 14

all categories:
- slide 9: category-specific AR language (room visualization,
  fit prediction, size visualization, jewellery try-on)
- slide 12: category-specific cross-sell subtitle (expert-grade,
  travel-kit, activity-kit, jeweller-grade, room-grade)
- slide 12: category-specific follow-up attributes

clothing:
- slide 5: replace "16GM RAM" with "cotton kurta"
- slide 8: replace "plan my meals" with fashion query
- slide 10: rich fashion-specific virtual try-on copy

electronics: slide 10 title "AR Room Visualization"
bags: slide 5 fix cabin limits mapping
shoes: slide 5 fix beach wedding → dressy sandal
jewellery: slide 5 fix mangalsutra mapping

Co-Authored-By: Claude Opus 4.6 (1M context) <noreply@anthropic.com>
</commit_message>
<xml_diff>
--- a/_base_template.pptx
+++ b/_base_template.pptx
@@ -4875,7 +4875,7 @@
                 <a:cs typeface="Inter"/>
                 <a:sym typeface="Inter"/>
               </a:rPr>
-              <a:t>Conversational AI shopping assistants for for e-commerce websites</a:t>
+              <a:t>Conversational AI shopping assistants for e-commerce websites</a:t>
             </a:r>
             <a:endParaRPr b="0" i="0" sz="1600" u="none" cap="none" strike="noStrike">
               <a:solidFill>
@@ -10424,7 +10424,7 @@
                 <a:cs typeface="Inter"/>
                 <a:sym typeface="Inter"/>
               </a:rPr>
-              <a:t>We can run a full 500-query audit on your site in under a week and show you exactly where you are losing crores in revenue..</a:t>
+              <a:t>We can run a full 500-query audit on your site in under a week and show you exactly where you are losing crores in revenue.</a:t>
             </a:r>
             <a:endParaRPr b="0" i="0" sz="1500" u="none" cap="none" strike="noStrike">
               <a:solidFill>

</xml_diff>